<commit_message>
Add agent skills and update inno template
</commit_message>
<xml_diff>
--- a/md2ppt/refs/inno.pptx
+++ b/md2ppt/refs/inno.pptx
@@ -201,7 +201,7 @@
           <a:p>
             <a:fld id="{0CF6306B-74C6-467E-AC1D-970CEB081CA9}" type="datetimeFigureOut">
               <a:rPr lang="ko-KR" altLang="en-US" smtClean="0"/>
-              <a:t>2026-05-28</a:t>
+              <a:t>2026-06-03</a:t>
             </a:fld>
             <a:endParaRPr lang="ko-KR" altLang="en-US"/>
           </a:p>
@@ -937,7 +937,7 @@
           <a:p>
             <a:fld id="{FCBE9B9B-CD13-41F7-AB29-0ED4C0FF6443}" type="datetimeFigureOut">
               <a:rPr lang="ko-KR" altLang="en-US" smtClean="0"/>
-              <a:t>2026-05-28</a:t>
+              <a:t>2026-06-03</a:t>
             </a:fld>
             <a:endParaRPr lang="ko-KR" altLang="en-US"/>
           </a:p>
@@ -1123,7 +1123,7 @@
           <a:p>
             <a:fld id="{FCBE9B9B-CD13-41F7-AB29-0ED4C0FF6443}" type="datetimeFigureOut">
               <a:rPr lang="ko-KR" altLang="en-US" smtClean="0"/>
-              <a:t>2026-05-28</a:t>
+              <a:t>2026-06-03</a:t>
             </a:fld>
             <a:endParaRPr lang="ko-KR" altLang="en-US"/>
           </a:p>
@@ -1319,7 +1319,7 @@
           <a:p>
             <a:fld id="{FCBE9B9B-CD13-41F7-AB29-0ED4C0FF6443}" type="datetimeFigureOut">
               <a:rPr lang="ko-KR" altLang="en-US" smtClean="0"/>
-              <a:t>2026-05-28</a:t>
+              <a:t>2026-06-03</a:t>
             </a:fld>
             <a:endParaRPr lang="ko-KR" altLang="en-US"/>
           </a:p>
@@ -1626,7 +1626,7 @@
 
 <file path=ppt/slideLayouts/slideLayout3.xml><?xml version="1.0" encoding="utf-8"?>
 <p:sldLayout xmlns:a="http://schemas.openxmlformats.org/drawingml/2006/main" xmlns:r="http://schemas.openxmlformats.org/officeDocument/2006/relationships" xmlns:p="http://schemas.openxmlformats.org/presentationml/2006/main" preserve="1" userDrawn="1">
-  <p:cSld name="TOC_">
+  <p:cSld name="TOC">
     <p:spTree>
       <p:nvGrpSpPr>
         <p:cNvPr id="1" name=""/>
@@ -2676,7 +2676,7 @@
           <a:p>
             <a:fld id="{FCBE9B9B-CD13-41F7-AB29-0ED4C0FF6443}" type="datetimeFigureOut">
               <a:rPr lang="ko-KR" altLang="en-US" smtClean="0"/>
-              <a:t>2026-05-28</a:t>
+              <a:t>2026-06-03</a:t>
             </a:fld>
             <a:endParaRPr lang="ko-KR" altLang="en-US"/>
           </a:p>

</xml_diff>

<commit_message>
Add named shape metadata support
</commit_message>
<xml_diff>
--- a/md2ppt/refs/inno.pptx
+++ b/md2ppt/refs/inno.pptx
@@ -201,7 +201,7 @@
           <a:p>
             <a:fld id="{0CF6306B-74C6-467E-AC1D-970CEB081CA9}" type="datetimeFigureOut">
               <a:rPr lang="ko-KR" altLang="en-US" smtClean="0"/>
-              <a:t>2026-06-03</a:t>
+              <a:t>2026-06-04</a:t>
             </a:fld>
             <a:endParaRPr lang="ko-KR" altLang="en-US"/>
           </a:p>
@@ -651,7 +651,7 @@
       </p:sp>
       <p:sp>
         <p:nvSpPr>
-          <p:cNvPr id="3" name="Subtitle 2"/>
+          <p:cNvPr id="3" name="{&quot;id&quot;: &quot;subtitle&quot;, &quot;show_anyway&quot;: true}"/>
           <p:cNvSpPr>
             <a:spLocks noGrp="1"/>
           </p:cNvSpPr>
@@ -937,7 +937,7 @@
           <a:p>
             <a:fld id="{FCBE9B9B-CD13-41F7-AB29-0ED4C0FF6443}" type="datetimeFigureOut">
               <a:rPr lang="ko-KR" altLang="en-US" smtClean="0"/>
-              <a:t>2026-06-03</a:t>
+              <a:t>2026-06-04</a:t>
             </a:fld>
             <a:endParaRPr lang="ko-KR" altLang="en-US"/>
           </a:p>
@@ -1123,7 +1123,7 @@
           <a:p>
             <a:fld id="{FCBE9B9B-CD13-41F7-AB29-0ED4C0FF6443}" type="datetimeFigureOut">
               <a:rPr lang="ko-KR" altLang="en-US" smtClean="0"/>
-              <a:t>2026-06-03</a:t>
+              <a:t>2026-06-04</a:t>
             </a:fld>
             <a:endParaRPr lang="ko-KR" altLang="en-US"/>
           </a:p>
@@ -1319,7 +1319,7 @@
           <a:p>
             <a:fld id="{FCBE9B9B-CD13-41F7-AB29-0ED4C0FF6443}" type="datetimeFigureOut">
               <a:rPr lang="ko-KR" altLang="en-US" smtClean="0"/>
-              <a:t>2026-06-03</a:t>
+              <a:t>2026-06-04</a:t>
             </a:fld>
             <a:endParaRPr lang="ko-KR" altLang="en-US"/>
           </a:p>
@@ -1945,7 +1945,7 @@
       </p:sp>
       <p:sp>
         <p:nvSpPr>
-          <p:cNvPr id="3" name="Text Placeholder 2"/>
+          <p:cNvPr id="3" name="{&quot;id&quot;: &quot;section_index&quot;, &quot;show_anyway&quot;: false}"/>
           <p:cNvSpPr>
             <a:spLocks noGrp="1"/>
           </p:cNvSpPr>
@@ -2676,7 +2676,7 @@
           <a:p>
             <a:fld id="{FCBE9B9B-CD13-41F7-AB29-0ED4C0FF6443}" type="datetimeFigureOut">
               <a:rPr lang="ko-KR" altLang="en-US" smtClean="0"/>
-              <a:t>2026-06-03</a:t>
+              <a:t>2026-06-04</a:t>
             </a:fld>
             <a:endParaRPr lang="ko-KR" altLang="en-US"/>
           </a:p>

</xml_diff>